<commit_message>
Sync from private lab repo (2026-10-26): tiered patching with health gates, custom EE, GitOps inventory
Major updates brought over from the private development repo:
- patching_idm: IdM patching with ipactl service verification
- patching_aap: controller-host patching with pre/post platform health gates
- patching_history: shared audit CSV + per-host transaction detail files
- standardise_dns: declarative fleet resolver configuration
- inventory.ini: canonical inventory, context-free (controller-native)
- delegation refactor: report writes target the collector group, not localhost
- vars_prompt removal: playbooks unattended-safe for EE/cron execution
- scripts/joblog.sh: fetch complete job output via the AAP API
- ansible.cfg: vault via environment (EE-safe), no control-node assumptions

All content audited: no client identifiers, no credentials, no private-repo
references.
</commit_message>
<xml_diff>
--- a/docs/architecture/export/Linux-Fleet-Automation-Architecture-Overview.pptx
+++ b/docs/architecture/export/Linux-Fleet-Automation-Architecture-Overview.pptx
@@ -2270,7 +2270,7 @@
       </p:sp>
       <p:pic>
         <p:nvPicPr>
-          <p:cNvPr id="4" name="Image 0" descr="docs/architecture/export/01-system-overview.png">    </p:cNvPr>
+          <p:cNvPr id="4" name="Image 0" descr="/home/user/workspace/ansible_operations/docs/architecture/export/01-system-overview.png">    </p:cNvPr>
           <p:cNvPicPr>
             <a:picLocks noChangeAspect="1"/>
           </p:cNvPicPr>
@@ -2482,7 +2482,7 @@
       </p:sp>
       <p:pic>
         <p:nvPicPr>
-          <p:cNvPr id="4" name="Image 0" descr="docs/architecture/export/02-log-collector-pipelines.png">    </p:cNvPr>
+          <p:cNvPr id="4" name="Image 0" descr="/home/user/workspace/ansible_operations/docs/architecture/export/02-log-collector-pipelines.png">    </p:cNvPr>
           <p:cNvPicPr>
             <a:picLocks noChangeAspect="1"/>
           </p:cNvPicPr>
@@ -2694,7 +2694,7 @@
       </p:sp>
       <p:pic>
         <p:nvPicPr>
-          <p:cNvPr id="4" name="Image 0" descr="docs/architecture/export/03-centralized-logging-role-order.png">    </p:cNvPr>
+          <p:cNvPr id="4" name="Image 0" descr="/home/user/workspace/ansible_operations/docs/architecture/export/03-centralized-logging-role-order.png">    </p:cNvPr>
           <p:cNvPicPr>
             <a:picLocks noChangeAspect="1"/>
           </p:cNvPicPr>

</xml_diff>